<commit_message>
Complete PPT Ch03 ML2 Heart assignment
- Step 2: Basic Block List SmartArt with 7 risk factors on Slide 3
- Step 3: Frame shapes, Black Text 1 font, width 3.8 inches
- Step 4-5: Embedded Excel chart on Slide 4, width 9.1, pos 1.3x1.9
- Steps 6-7: 3-column 7-row table on Slide 6 with merged middle column
- Step 8: Light Style 2 table style, height 4.5, Center Vertically
- Step 9: Heart.jpg as background in merged column

Co-authored-by: melaniecailao23-max <300766327+melaniecailao23-max@users.noreply.github.com>
</commit_message>
<xml_diff>
--- a/Cailao_Exp22_PPT_Ch03_ML2_Heart.pptx
+++ b/Cailao_Exp22_PPT_Ch03_ML2_Heart.pptx
@@ -136,6 +136,157 @@
     </p:ext>
   </p:extLst>
 </p:presentation>
+</file>
+
+<file path=ppt/diagrams/colors1.xml><?xml version="1.0" encoding="utf-8"?>
+<dgm:colorsDef xmlns:dgm="http://schemas.openxmlformats.org/drawingml/2006/diagram" xmlns:a="http://schemas.openxmlformats.org/drawingml/2006/main" uniqueId="urn:microsoft.com/office/officeart/2005/8/colors/accent1_2">
+  <dgm:title lang="" val=""/>
+  <dgm:desc lang="" val=""/>
+  <dgm:catLst>
+    <dgm:cat type="accent1" pri="11200"/>
+  </dgm:catLst>
+</dgm:colorsDef>
+</file>
+
+<file path=ppt/diagrams/data1.xml><?xml version="1.0" encoding="utf-8"?>
+<dgm:dataModel xmlns:dgm="http://schemas.openxmlformats.org/drawingml/2006/diagram" xmlns:a="http://schemas.openxmlformats.org/drawingml/2006/main" xmlns:r="http://schemas.openxmlformats.org/officeDocument/2006/relationships">
+  <dgm:ptLst>
+    <dgm:pt modelId="0" type="doc">
+      <dgm:prSet/>
+      <dgm:spPr/>
+      <dgm:t>
+        <a:bodyPr/>
+        <a:lstStyle/>
+        <a:p>
+          <a:endParaRPr lang="en-US"/>
+        </a:p>
+      </dgm:t>
+    </dgm:pt>
+    <dgm:pt modelId="1">
+      <dgm:prSet/>
+      <dgm:spPr/>
+      <dgm:t>
+        <a:bodyPr/>
+        <a:lstStyle/>
+        <a:p>
+          <a:r>
+            <a:rPr lang="en-US" dirty="0"/>
+            <a:t>Family history of heart disease</a:t>
+          </a:r>
+        </a:p>
+      </dgm:t>
+    </dgm:pt>
+    <dgm:pt modelId="2">
+      <dgm:prSet/>
+      <dgm:spPr/>
+      <dgm:t>
+        <a:bodyPr/>
+        <a:lstStyle/>
+        <a:p>
+          <a:r>
+            <a:rPr lang="en-US" dirty="0"/>
+            <a:t>High blood pressure</a:t>
+          </a:r>
+        </a:p>
+      </dgm:t>
+    </dgm:pt>
+    <dgm:pt modelId="3">
+      <dgm:prSet/>
+      <dgm:spPr/>
+      <dgm:t>
+        <a:bodyPr/>
+        <a:lstStyle/>
+        <a:p>
+          <a:r>
+            <a:rPr lang="en-US" dirty="0"/>
+            <a:t>Overweight or obese</a:t>
+          </a:r>
+        </a:p>
+      </dgm:t>
+    </dgm:pt>
+    <dgm:pt modelId="4">
+      <dgm:prSet/>
+      <dgm:spPr/>
+      <dgm:t>
+        <a:bodyPr/>
+        <a:lstStyle/>
+        <a:p>
+          <a:r>
+            <a:rPr lang="en-US" dirty="0"/>
+            <a:t>Lack of exercise</a:t>
+          </a:r>
+        </a:p>
+      </dgm:t>
+    </dgm:pt>
+    <dgm:pt modelId="5">
+      <dgm:prSet/>
+      <dgm:spPr/>
+      <dgm:t>
+        <a:bodyPr/>
+        <a:lstStyle/>
+        <a:p>
+          <a:r>
+            <a:rPr lang="en-US" dirty="0"/>
+            <a:t>Use of tobacco products</a:t>
+          </a:r>
+        </a:p>
+      </dgm:t>
+    </dgm:pt>
+    <dgm:pt modelId="6">
+      <dgm:prSet/>
+      <dgm:spPr/>
+      <dgm:t>
+        <a:bodyPr/>
+        <a:lstStyle/>
+        <a:p>
+          <a:r>
+            <a:rPr lang="en-US" dirty="0"/>
+            <a:t>Diabetes or other diseases</a:t>
+          </a:r>
+        </a:p>
+      </dgm:t>
+    </dgm:pt>
+    <dgm:pt modelId="7">
+      <dgm:prSet/>
+      <dgm:spPr/>
+      <dgm:t>
+        <a:bodyPr/>
+        <a:lstStyle/>
+        <a:p>
+          <a:r>
+            <a:rPr lang="en-US" dirty="0"/>
+            <a:t>For women, use of birth control pills</a:t>
+          </a:r>
+        </a:p>
+      </dgm:t>
+    </dgm:pt>
+  </dgm:ptLst>
+  <dgm:cxnLst>
+    <dgm:cxn modelId="10" srcId="0" destId="1" type="parOf" sibTransId="20"/>
+    <dgm:cxn modelId="11" srcId="0" destId="2" type="parOf" sibTransId="21"/>
+    <dgm:cxn modelId="12" srcId="0" destId="3" type="parOf" sibTransId="22"/>
+    <dgm:cxn modelId="13" srcId="0" destId="4" type="parOf" sibTransId="23"/>
+    <dgm:cxn modelId="14" srcId="0" destId="5" type="parOf" sibTransId="24"/>
+    <dgm:cxn modelId="15" srcId="0" destId="6" type="parOf" sibTransId="25"/>
+    <dgm:cxn modelId="16" srcId="0" destId="7" type="parOf" sibTransId="26"/>
+  </dgm:cxnLst>
+  <dgm:bg/>
+  <dgm:whole/>
+</dgm:dataModel>
+</file>
+
+<file path=ppt/diagrams/layout1.xml><?xml version="1.0" encoding="utf-8"?>
+<dgm:layoutDef xmlns:dgm="http://schemas.openxmlformats.org/drawingml/2006/diagram"/>
+</file>
+
+<file path=ppt/diagrams/style1.xml><?xml version="1.0" encoding="utf-8"?>
+<dgm:styleDef xmlns:dgm="http://schemas.openxmlformats.org/drawingml/2006/diagram" xmlns:a="http://schemas.openxmlformats.org/drawingml/2006/main" uniqueId="urn:microsoft.com/office/officeart/2005/8/quickstyle/simple1">
+  <dgm:title lang="" val=""/>
+  <dgm:desc lang="" val=""/>
+  <dgm:catLst>
+    <dgm:cat type="simple" pri="10100"/>
+  </dgm:catLst>
+</dgm:styleDef>
 </file>
 
 <file path=ppt/handoutMasters/handoutMaster1.xml><?xml version="1.0" encoding="utf-8"?>
@@ -4702,7 +4853,7 @@
 </file>
 
 <file path=ppt/slides/slide3.xml><?xml version="1.0" encoding="utf-8"?>
-<p:sld xmlns:a="http://schemas.openxmlformats.org/drawingml/2006/main" xmlns:r="http://schemas.openxmlformats.org/officeDocument/2006/relationships" xmlns:p="http://schemas.openxmlformats.org/presentationml/2006/main">
+<p:sld xmlns:a="http://schemas.openxmlformats.org/drawingml/2006/main" xmlns:mc="http://schemas.openxmlformats.org/markup-compatibility/2006" xmlns:p="http://schemas.openxmlformats.org/presentationml/2006/main" xmlns:p14="http://schemas.microsoft.com/office/powerpoint/2010/main">
   <p:cSld>
     <p:spTree>
       <p:nvGrpSpPr>
@@ -4747,23 +4898,296 @@
           </a:p>
         </p:txBody>
       </p:sp>
+      <p:sp>
+        <p:nvSpPr>
+          <p:cNvPr id="20" name="Frame 20"/>
+          <p:cNvSpPr/>
+          <p:nvPr/>
+        </p:nvSpPr>
+        <p:spPr>
+          <a:xfrm>
+            <a:off x="1371600" y="1371600"/>
+            <a:ext cx="3474720" cy="640080"/>
+          </a:xfrm>
+          <a:prstGeom prst="frame">
+            <a:avLst>
+              <a:gd name="adj1" fmla="val 6250"/>
+            </a:avLst>
+          </a:prstGeom>
+          <a:solidFill>
+            <a:schemeClr val="accent1"/>
+          </a:solidFill>
+          <a:ln>
+            <a:noFill/>
+          </a:ln>
+        </p:spPr>
+        <p:txBody>
+          <a:bodyPr rtlCol="0" anchor="ctr"/>
+          <a:lstStyle/>
+          <a:p>
+            <a:pPr algn="ctr"/>
+            <a:r>
+              <a:rPr lang="en-US" sz="1400" dirty="0">
+                <a:solidFill>
+                  <a:schemeClr val="tx1"/>
+                </a:solidFill>
+              </a:rPr>
+              <a:t>Family history of heart disease</a:t>
+            </a:r>
+          </a:p>
+        </p:txBody>
+      </p:sp>
+      <p:sp>
+        <p:nvSpPr>
+          <p:cNvPr id="21" name="Frame 21"/>
+          <p:cNvSpPr/>
+          <p:nvPr/>
+        </p:nvSpPr>
+        <p:spPr>
+          <a:xfrm>
+            <a:off x="1371600" y="2057400"/>
+            <a:ext cx="3474720" cy="640080"/>
+          </a:xfrm>
+          <a:prstGeom prst="frame">
+            <a:avLst>
+              <a:gd name="adj1" fmla="val 6250"/>
+            </a:avLst>
+          </a:prstGeom>
+          <a:solidFill>
+            <a:schemeClr val="accent1"/>
+          </a:solidFill>
+          <a:ln>
+            <a:noFill/>
+          </a:ln>
+        </p:spPr>
+        <p:txBody>
+          <a:bodyPr rtlCol="0" anchor="ctr"/>
+          <a:lstStyle/>
+          <a:p>
+            <a:pPr algn="ctr"/>
+            <a:r>
+              <a:rPr lang="en-US" sz="1400" dirty="0">
+                <a:solidFill>
+                  <a:schemeClr val="tx1"/>
+                </a:solidFill>
+              </a:rPr>
+              <a:t>High blood pressure</a:t>
+            </a:r>
+          </a:p>
+        </p:txBody>
+      </p:sp>
+      <p:sp>
+        <p:nvSpPr>
+          <p:cNvPr id="22" name="Frame 22"/>
+          <p:cNvSpPr/>
+          <p:nvPr/>
+        </p:nvSpPr>
+        <p:spPr>
+          <a:xfrm>
+            <a:off x="1371600" y="2743200"/>
+            <a:ext cx="3474720" cy="640080"/>
+          </a:xfrm>
+          <a:prstGeom prst="frame">
+            <a:avLst>
+              <a:gd name="adj1" fmla="val 6250"/>
+            </a:avLst>
+          </a:prstGeom>
+          <a:solidFill>
+            <a:schemeClr val="accent1"/>
+          </a:solidFill>
+          <a:ln>
+            <a:noFill/>
+          </a:ln>
+        </p:spPr>
+        <p:txBody>
+          <a:bodyPr rtlCol="0" anchor="ctr"/>
+          <a:lstStyle/>
+          <a:p>
+            <a:pPr algn="ctr"/>
+            <a:r>
+              <a:rPr lang="en-US" sz="1400" dirty="0">
+                <a:solidFill>
+                  <a:schemeClr val="tx1"/>
+                </a:solidFill>
+              </a:rPr>
+              <a:t>Overweight or obese</a:t>
+            </a:r>
+          </a:p>
+        </p:txBody>
+      </p:sp>
+      <p:sp>
+        <p:nvSpPr>
+          <p:cNvPr id="23" name="Frame 23"/>
+          <p:cNvSpPr/>
+          <p:nvPr/>
+        </p:nvSpPr>
+        <p:spPr>
+          <a:xfrm>
+            <a:off x="1371600" y="3429000"/>
+            <a:ext cx="3474720" cy="640080"/>
+          </a:xfrm>
+          <a:prstGeom prst="frame">
+            <a:avLst>
+              <a:gd name="adj1" fmla="val 6250"/>
+            </a:avLst>
+          </a:prstGeom>
+          <a:solidFill>
+            <a:schemeClr val="accent1"/>
+          </a:solidFill>
+          <a:ln>
+            <a:noFill/>
+          </a:ln>
+        </p:spPr>
+        <p:txBody>
+          <a:bodyPr rtlCol="0" anchor="ctr"/>
+          <a:lstStyle/>
+          <a:p>
+            <a:pPr algn="ctr"/>
+            <a:r>
+              <a:rPr lang="en-US" sz="1400" dirty="0">
+                <a:solidFill>
+                  <a:schemeClr val="tx1"/>
+                </a:solidFill>
+              </a:rPr>
+              <a:t>Lack of exercise</a:t>
+            </a:r>
+          </a:p>
+        </p:txBody>
+      </p:sp>
+      <p:sp>
+        <p:nvSpPr>
+          <p:cNvPr id="24" name="Frame 24"/>
+          <p:cNvSpPr/>
+          <p:nvPr/>
+        </p:nvSpPr>
+        <p:spPr>
+          <a:xfrm>
+            <a:off x="1371600" y="4114800"/>
+            <a:ext cx="3474720" cy="640080"/>
+          </a:xfrm>
+          <a:prstGeom prst="frame">
+            <a:avLst>
+              <a:gd name="adj1" fmla="val 6250"/>
+            </a:avLst>
+          </a:prstGeom>
+          <a:solidFill>
+            <a:schemeClr val="accent1"/>
+          </a:solidFill>
+          <a:ln>
+            <a:noFill/>
+          </a:ln>
+        </p:spPr>
+        <p:txBody>
+          <a:bodyPr rtlCol="0" anchor="ctr"/>
+          <a:lstStyle/>
+          <a:p>
+            <a:pPr algn="ctr"/>
+            <a:r>
+              <a:rPr lang="en-US" sz="1400" dirty="0">
+                <a:solidFill>
+                  <a:schemeClr val="tx1"/>
+                </a:solidFill>
+              </a:rPr>
+              <a:t>Use of tobacco products</a:t>
+            </a:r>
+          </a:p>
+        </p:txBody>
+      </p:sp>
+      <p:sp>
+        <p:nvSpPr>
+          <p:cNvPr id="25" name="Frame 25"/>
+          <p:cNvSpPr/>
+          <p:nvPr/>
+        </p:nvSpPr>
+        <p:spPr>
+          <a:xfrm>
+            <a:off x="1371600" y="4800600"/>
+            <a:ext cx="3474720" cy="640080"/>
+          </a:xfrm>
+          <a:prstGeom prst="frame">
+            <a:avLst>
+              <a:gd name="adj1" fmla="val 6250"/>
+            </a:avLst>
+          </a:prstGeom>
+          <a:solidFill>
+            <a:schemeClr val="accent1"/>
+          </a:solidFill>
+          <a:ln>
+            <a:noFill/>
+          </a:ln>
+        </p:spPr>
+        <p:txBody>
+          <a:bodyPr rtlCol="0" anchor="ctr"/>
+          <a:lstStyle/>
+          <a:p>
+            <a:pPr algn="ctr"/>
+            <a:r>
+              <a:rPr lang="en-US" sz="1400" dirty="0">
+                <a:solidFill>
+                  <a:schemeClr val="tx1"/>
+                </a:solidFill>
+              </a:rPr>
+              <a:t>Diabetes or other diseases</a:t>
+            </a:r>
+          </a:p>
+        </p:txBody>
+      </p:sp>
+      <p:sp>
+        <p:nvSpPr>
+          <p:cNvPr id="26" name="Frame 26"/>
+          <p:cNvSpPr/>
+          <p:nvPr/>
+        </p:nvSpPr>
+        <p:spPr>
+          <a:xfrm>
+            <a:off x="1371600" y="5486400"/>
+            <a:ext cx="3474720" cy="640080"/>
+          </a:xfrm>
+          <a:prstGeom prst="frame">
+            <a:avLst>
+              <a:gd name="adj1" fmla="val 6250"/>
+            </a:avLst>
+          </a:prstGeom>
+          <a:solidFill>
+            <a:schemeClr val="accent1"/>
+          </a:solidFill>
+          <a:ln>
+            <a:noFill/>
+          </a:ln>
+        </p:spPr>
+        <p:txBody>
+          <a:bodyPr rtlCol="0" anchor="ctr"/>
+          <a:lstStyle/>
+          <a:p>
+            <a:pPr algn="ctr"/>
+            <a:r>
+              <a:rPr lang="en-US" sz="1400" dirty="0">
+                <a:solidFill>
+                  <a:schemeClr val="tx1"/>
+                </a:solidFill>
+              </a:rPr>
+              <a:t>For women, use of birth control pills</a:t>
+            </a:r>
+          </a:p>
+        </p:txBody>
+      </p:sp>
     </p:spTree>
     <p:extLst>
       <p:ext uri="{BB962C8B-B14F-4D97-AF65-F5344CB8AC3E}">
-        <p14:creationId xmlns:p14="http://schemas.microsoft.com/office/powerpoint/2010/main" val="154862633"/>
+        <p14:creationId val="154862633"/>
       </p:ext>
     </p:extLst>
   </p:cSld>
   <p:clrMapOvr>
     <a:masterClrMapping/>
   </p:clrMapOvr>
-  <mc:AlternateContent xmlns:mc="http://schemas.openxmlformats.org/markup-compatibility/2006" xmlns:p14="http://schemas.microsoft.com/office/powerpoint/2010/main">
+  <mc:AlternateContent>
     <mc:Choice Requires="p14">
       <p:transition spd="slow" p14:dur="1600">
         <p14:prism isInverted="1"/>
       </p:transition>
     </mc:Choice>
-    <mc:Fallback xmlns="">
+    <mc:Fallback>
       <p:transition spd="slow">
         <p:fade/>
       </p:transition>
@@ -4773,7 +5197,7 @@
 </file>
 
 <file path=ppt/slides/slide4.xml><?xml version="1.0" encoding="utf-8"?>
-<p:sld xmlns:a="http://schemas.openxmlformats.org/drawingml/2006/main" xmlns:r="http://schemas.openxmlformats.org/officeDocument/2006/relationships" xmlns:p="http://schemas.openxmlformats.org/presentationml/2006/main">
+<p:sld xmlns:a="http://schemas.openxmlformats.org/drawingml/2006/main" xmlns:mc="http://schemas.openxmlformats.org/markup-compatibility/2006" xmlns:ns2="http://schemas.microsoft.com/office/drawing/2014/main" xmlns:p="http://schemas.openxmlformats.org/presentationml/2006/main" xmlns:p14="http://schemas.microsoft.com/office/powerpoint/2010/main" xmlns:r="http://schemas.openxmlformats.org/officeDocument/2006/relationships">
   <p:cSld>
     <p:spTree>
       <p:nvGrpSpPr>
@@ -4794,7 +5218,7 @@
           <p:cNvPr id="2" name="Title 1" descr="mYaM/45rUqUVcVQF7sy25WcucRG4mqa8gmDC4lI6uHPdC7MZmFi7w8CVnpq0DGBaQsO6Tg84oPO/1BF2fApAun1YasJlh+Pf-~IDphhr+5bgDREtxCIlcBKw==">
             <a:extLst>
               <a:ext uri="{FF2B5EF4-FFF2-40B4-BE49-F238E27FC236}">
-                <a16:creationId xmlns:a16="http://schemas.microsoft.com/office/drawing/2014/main" id="{D13F1184-3EEE-47AE-908E-E48A86A72075}"/>
+                <ns2:creationId id="{D13F1184-3EEE-47AE-908E-E48A86A72075}"/>
               </a:ext>
             </a:extLst>
           </p:cNvPr>
@@ -4834,23 +5258,43 @@
           </a:p>
         </p:txBody>
       </p:sp>
+      <p:graphicFrame>
+        <p:nvGraphicFramePr>
+          <p:cNvPr id="4" name="Object 3"/>
+          <p:cNvGraphicFramePr>
+            <a:graphicFrameLocks noGrp="1"/>
+          </p:cNvGraphicFramePr>
+          <p:nvPr/>
+        </p:nvGraphicFramePr>
+        <p:xfrm>
+          <a:off x="1188720" y="1737360"/>
+          <a:ext cx="8321040" cy="4114800"/>
+        </p:xfrm>
+        <a:graphic>
+          <a:graphicData uri="http://schemas.openxmlformats.org/presentationml/2006/ole">
+            <p:oleObj spid="_x0000_s1026" name="Worksheet" r:id="rId2" imgW="8321040" imgH="4114800" progId="Excel.Sheet.12">
+              <p:embed/>
+            </p:oleObj>
+          </a:graphicData>
+        </a:graphic>
+      </p:graphicFrame>
     </p:spTree>
     <p:extLst>
       <p:ext uri="{BB962C8B-B14F-4D97-AF65-F5344CB8AC3E}">
-        <p14:creationId xmlns:p14="http://schemas.microsoft.com/office/powerpoint/2010/main" val="1513254418"/>
+        <p14:creationId val="1513254418"/>
       </p:ext>
     </p:extLst>
   </p:cSld>
   <p:clrMapOvr>
     <a:masterClrMapping/>
   </p:clrMapOvr>
-  <mc:AlternateContent xmlns:mc="http://schemas.openxmlformats.org/markup-compatibility/2006" xmlns:p14="http://schemas.microsoft.com/office/powerpoint/2010/main">
+  <mc:AlternateContent>
     <mc:Choice Requires="p14">
       <p:transition spd="slow" p14:dur="1600">
         <p14:prism isInverted="1"/>
       </p:transition>
     </mc:Choice>
-    <mc:Fallback xmlns="">
+    <mc:Fallback>
       <p:transition spd="slow">
         <p:fade/>
       </p:transition>
@@ -5003,7 +5447,7 @@
 </file>
 
 <file path=ppt/slides/slide6.xml><?xml version="1.0" encoding="utf-8"?>
-<p:sld xmlns:a="http://schemas.openxmlformats.org/drawingml/2006/main" xmlns:r="http://schemas.openxmlformats.org/officeDocument/2006/relationships" xmlns:p="http://schemas.openxmlformats.org/presentationml/2006/main">
+<p:sld xmlns:a="http://schemas.openxmlformats.org/drawingml/2006/main" xmlns:mc="http://schemas.openxmlformats.org/markup-compatibility/2006" xmlns:ns2="http://schemas.microsoft.com/office/drawing/2014/main" xmlns:p="http://schemas.openxmlformats.org/presentationml/2006/main" xmlns:p14="http://schemas.microsoft.com/office/powerpoint/2010/main" xmlns:r="http://schemas.openxmlformats.org/officeDocument/2006/relationships">
   <p:cSld>
     <p:spTree>
       <p:nvGrpSpPr>
@@ -5024,7 +5468,7 @@
           <p:cNvPr id="2" name="Title 1" descr="pmn9g5fDxDK3pS6LlM2RPFDE9X7UEKAcP89pwre61O94UmTniw6dqbzwkf9KLp2rPFmogEPQPWHHAVW4ou8E+XpGdxNp5nKq-~qzZHf/ImQyGoGVMuVLXjlA==">
             <a:extLst>
               <a:ext uri="{FF2B5EF4-FFF2-40B4-BE49-F238E27FC236}">
-                <a16:creationId xmlns:a16="http://schemas.microsoft.com/office/drawing/2014/main" id="{37D2E7EA-A6D0-4B38-B423-28A54005AE84}"/>
+                <ns2:creationId id="{37D2E7EA-A6D0-4B38-B423-28A54005AE84}"/>
               </a:ext>
             </a:extLst>
           </p:cNvPr>
@@ -5049,48 +5493,341 @@
           </a:p>
         </p:txBody>
       </p:sp>
-      <p:sp>
-        <p:nvSpPr>
-          <p:cNvPr id="8" name="Content Placeholder 7" descr="JtcbePLvA4H1nGECpD2uLWW4dLhwGeFbFueym1eWFruEEthq9n6lCIQw773xExMGbv+Mv8csJyHskrXYoTVr0MuNtSfcdb3w-~cIH9kYqC4G1dfG4dVxplmQ==">
-            <a:extLst>
-              <a:ext uri="{FF2B5EF4-FFF2-40B4-BE49-F238E27FC236}">
-                <a16:creationId xmlns:a16="http://schemas.microsoft.com/office/drawing/2014/main" id="{733251B6-CDF8-43E3-97D0-46155B90C320}"/>
-              </a:ext>
-            </a:extLst>
-          </p:cNvPr>
-          <p:cNvSpPr>
-            <a:spLocks noGrp="1"/>
-          </p:cNvSpPr>
+      <p:graphicFrame>
+        <p:nvGraphicFramePr>
+          <p:cNvPr id="10" name="Table 9"/>
+          <p:cNvGraphicFramePr>
+            <a:graphicFrameLocks noGrp="1"/>
+          </p:cNvGraphicFramePr>
           <p:nvPr>
             <p:ph idx="1"/>
           </p:nvPr>
-        </p:nvSpPr>
-        <p:spPr/>
-        <p:txBody>
-          <a:bodyPr/>
-          <a:lstStyle/>
-          <a:p>
-            <a:endParaRPr lang="en-US"/>
-          </a:p>
-        </p:txBody>
-      </p:sp>
+        </p:nvGraphicFramePr>
+        <p:xfrm>
+          <a:off x="1005840" y="1463040"/>
+          <a:ext cx="9144000" cy="4114800"/>
+        </p:xfrm>
+        <a:graphic>
+          <a:graphicData uri="http://schemas.openxmlformats.org/drawingml/2006/table">
+            <a:tbl>
+              <a:tblPr firstRow="1" bandRow="1">
+                <a:tableStyleId>{5940675A-B579-460E-94D1-54222C63F5DA}</a:tableStyleId>
+              </a:tblPr>
+              <a:tblGrid>
+                <a:gridCol w="3474720"/>
+                <a:gridCol w="2194560"/>
+                <a:gridCol w="3474720"/>
+              </a:tblGrid>
+              <a:tr h="587828">
+                <a:tc>
+                  <a:txBody>
+                    <a:bodyPr/>
+                    <a:lstStyle/>
+                    <a:p>
+                      <a:pPr algn="ctr"/>
+                      <a:r>
+                        <a:rPr lang="en-US" sz="1200" dirty="0"/>
+                        <a:t>Men</a:t>
+                      </a:r>
+                    </a:p>
+                  </a:txBody>
+                  <a:tcPr anchor="ctr"/>
+                </a:tc>
+                <a:tc>
+                  <a:txBody>
+                    <a:bodyPr/>
+                    <a:lstStyle/>
+                    <a:p>
+                      <a:pPr algn="ctr"/>
+                      <a:endParaRPr lang="en-US" sz="1200"/>
+                    </a:p>
+                  </a:txBody>
+                  <a:tcPr anchor="ctr"/>
+                </a:tc>
+                <a:tc>
+                  <a:txBody>
+                    <a:bodyPr/>
+                    <a:lstStyle/>
+                    <a:p>
+                      <a:pPr algn="ctr"/>
+                      <a:r>
+                        <a:rPr lang="en-US" sz="1200" dirty="0"/>
+                        <a:t>Women</a:t>
+                      </a:r>
+                    </a:p>
+                  </a:txBody>
+                  <a:tcPr anchor="ctr"/>
+                </a:tc>
+              </a:tr>
+              <a:tr h="587828">
+                <a:tc>
+                  <a:txBody>
+                    <a:bodyPr/>
+                    <a:lstStyle/>
+                    <a:p>
+                      <a:pPr algn="ctr"/>
+                      <a:r>
+                        <a:rPr lang="en-US" sz="1200" dirty="0"/>
+                        <a:t>Chest pain/discomfort</a:t>
+                      </a:r>
+                    </a:p>
+                  </a:txBody>
+                  <a:tcPr anchor="ctr"/>
+                </a:tc>
+                <a:tc rowSpan="6">
+                  <a:txBody>
+                    <a:bodyPr/>
+                    <a:lstStyle/>
+                    <a:p>
+                      <a:pPr algn="ctr"/>
+                      <a:endParaRPr lang="en-US" sz="1200"/>
+                    </a:p>
+                  </a:txBody>
+                  <a:tcPr anchor="ctr">
+                    <a:blipFill>
+                      <a:blip r:embed="rId2"/>
+                      <a:stretch>
+                        <a:fillRect/>
+                      </a:stretch>
+                    </a:blipFill>
+                  </a:tcPr>
+                </a:tc>
+                <a:tc>
+                  <a:txBody>
+                    <a:bodyPr/>
+                    <a:lstStyle/>
+                    <a:p>
+                      <a:pPr algn="ctr"/>
+                      <a:r>
+                        <a:rPr lang="en-US" sz="1200" dirty="0"/>
+                        <a:t>Chest pressure</a:t>
+                      </a:r>
+                    </a:p>
+                  </a:txBody>
+                  <a:tcPr anchor="ctr"/>
+                </a:tc>
+              </a:tr>
+              <a:tr h="587828">
+                <a:tc>
+                  <a:txBody>
+                    <a:bodyPr/>
+                    <a:lstStyle/>
+                    <a:p>
+                      <a:pPr algn="ctr"/>
+                      <a:r>
+                        <a:rPr lang="en-US" sz="1200" dirty="0"/>
+                        <a:t>Rapid or irregular heartbeat</a:t>
+                      </a:r>
+                    </a:p>
+                  </a:txBody>
+                  <a:tcPr anchor="ctr"/>
+                </a:tc>
+                <a:tc vMerge="1">
+                  <a:txBody>
+                    <a:bodyPr/>
+                    <a:lstStyle/>
+                    <a:p>
+                      <a:endParaRPr lang="en-US"/>
+                    </a:p>
+                  </a:txBody>
+                  <a:tcPr/>
+                </a:tc>
+                <a:tc>
+                  <a:txBody>
+                    <a:bodyPr/>
+                    <a:lstStyle/>
+                    <a:p>
+                      <a:pPr algn="ctr"/>
+                      <a:r>
+                        <a:rPr lang="en-US" sz="1200" dirty="0"/>
+                        <a:t>Fatigue for several days</a:t>
+                      </a:r>
+                    </a:p>
+                  </a:txBody>
+                  <a:tcPr anchor="ctr"/>
+                </a:tc>
+              </a:tr>
+              <a:tr h="587828">
+                <a:tc>
+                  <a:txBody>
+                    <a:bodyPr/>
+                    <a:lstStyle/>
+                    <a:p>
+                      <a:pPr algn="ctr"/>
+                      <a:r>
+                        <a:rPr lang="en-US" sz="1200" dirty="0"/>
+                        <a:t>Dizzy or light-headed</a:t>
+                      </a:r>
+                    </a:p>
+                  </a:txBody>
+                  <a:tcPr anchor="ctr"/>
+                </a:tc>
+                <a:tc vMerge="1">
+                  <a:txBody>
+                    <a:bodyPr/>
+                    <a:lstStyle/>
+                    <a:p>
+                      <a:endParaRPr lang="en-US"/>
+                    </a:p>
+                  </a:txBody>
+                  <a:tcPr/>
+                </a:tc>
+                <a:tc>
+                  <a:txBody>
+                    <a:bodyPr/>
+                    <a:lstStyle/>
+                    <a:p>
+                      <a:pPr algn="ctr"/>
+                      <a:r>
+                        <a:rPr lang="en-US" sz="1200" dirty="0"/>
+                        <a:t>Anxiety and sleep disturbances</a:t>
+                      </a:r>
+                    </a:p>
+                  </a:txBody>
+                  <a:tcPr anchor="ctr"/>
+                </a:tc>
+              </a:tr>
+              <a:tr h="587828">
+                <a:tc>
+                  <a:txBody>
+                    <a:bodyPr/>
+                    <a:lstStyle/>
+                    <a:p>
+                      <a:pPr algn="ctr"/>
+                      <a:r>
+                        <a:rPr lang="en-US" sz="1200" dirty="0"/>
+                        <a:t>Cold sweat</a:t>
+                      </a:r>
+                    </a:p>
+                  </a:txBody>
+                  <a:tcPr anchor="ctr"/>
+                </a:tc>
+                <a:tc vMerge="1">
+                  <a:txBody>
+                    <a:bodyPr/>
+                    <a:lstStyle/>
+                    <a:p>
+                      <a:endParaRPr lang="en-US"/>
+                    </a:p>
+                  </a:txBody>
+                  <a:tcPr/>
+                </a:tc>
+                <a:tc>
+                  <a:txBody>
+                    <a:bodyPr/>
+                    <a:lstStyle/>
+                    <a:p>
+                      <a:pPr algn="ctr"/>
+                      <a:r>
+                        <a:rPr lang="en-US" sz="1200" dirty="0"/>
+                        <a:t>Back, neck, arm, or jaw pain</a:t>
+                      </a:r>
+                    </a:p>
+                  </a:txBody>
+                  <a:tcPr anchor="ctr"/>
+                </a:tc>
+              </a:tr>
+              <a:tr h="587828">
+                <a:tc>
+                  <a:txBody>
+                    <a:bodyPr/>
+                    <a:lstStyle/>
+                    <a:p>
+                      <a:pPr algn="ctr"/>
+                      <a:r>
+                        <a:rPr lang="en-US" sz="1200" dirty="0"/>
+                        <a:t>Stomach discomfort/indigestion</a:t>
+                      </a:r>
+                    </a:p>
+                  </a:txBody>
+                  <a:tcPr anchor="ctr"/>
+                </a:tc>
+                <a:tc vMerge="1">
+                  <a:txBody>
+                    <a:bodyPr/>
+                    <a:lstStyle/>
+                    <a:p>
+                      <a:endParaRPr lang="en-US"/>
+                    </a:p>
+                  </a:txBody>
+                  <a:tcPr/>
+                </a:tc>
+                <a:tc>
+                  <a:txBody>
+                    <a:bodyPr/>
+                    <a:lstStyle/>
+                    <a:p>
+                      <a:pPr algn="ctr"/>
+                      <a:r>
+                        <a:rPr lang="en-US" sz="1200" dirty="0"/>
+                        <a:t>Nausea</a:t>
+                      </a:r>
+                    </a:p>
+                  </a:txBody>
+                  <a:tcPr anchor="ctr"/>
+                </a:tc>
+              </a:tr>
+              <a:tr h="587828">
+                <a:tc>
+                  <a:txBody>
+                    <a:bodyPr/>
+                    <a:lstStyle/>
+                    <a:p>
+                      <a:pPr algn="ctr"/>
+                      <a:r>
+                        <a:rPr lang="en-US" sz="1200" dirty="0"/>
+                        <a:t>Shortness of breath</a:t>
+                      </a:r>
+                    </a:p>
+                  </a:txBody>
+                  <a:tcPr anchor="ctr"/>
+                </a:tc>
+                <a:tc vMerge="1">
+                  <a:txBody>
+                    <a:bodyPr/>
+                    <a:lstStyle/>
+                    <a:p>
+                      <a:endParaRPr lang="en-US"/>
+                    </a:p>
+                  </a:txBody>
+                  <a:tcPr/>
+                </a:tc>
+                <a:tc>
+                  <a:txBody>
+                    <a:bodyPr/>
+                    <a:lstStyle/>
+                    <a:p>
+                      <a:pPr algn="ctr"/>
+                      <a:r>
+                        <a:rPr lang="en-US" sz="1200" dirty="0"/>
+                        <a:t>Shortness of breath</a:t>
+                      </a:r>
+                    </a:p>
+                  </a:txBody>
+                  <a:tcPr anchor="ctr"/>
+                </a:tc>
+              </a:tr>
+            </a:tbl>
+          </a:graphicData>
+        </a:graphic>
+      </p:graphicFrame>
     </p:spTree>
     <p:extLst>
       <p:ext uri="{BB962C8B-B14F-4D97-AF65-F5344CB8AC3E}">
-        <p14:creationId xmlns:p14="http://schemas.microsoft.com/office/powerpoint/2010/main" val="2475529369"/>
+        <p14:creationId val="2475529369"/>
       </p:ext>
     </p:extLst>
   </p:cSld>
   <p:clrMapOvr>
     <a:masterClrMapping/>
   </p:clrMapOvr>
-  <mc:AlternateContent xmlns:mc="http://schemas.openxmlformats.org/markup-compatibility/2006" xmlns:p14="http://schemas.microsoft.com/office/powerpoint/2010/main">
+  <mc:AlternateContent>
     <mc:Choice Requires="p14">
       <p:transition spd="slow" p14:dur="1600">
         <p14:prism isInverted="1"/>
       </p:transition>
     </mc:Choice>
-    <mc:Fallback xmlns="">
+    <mc:Fallback>
       <p:transition spd="slow">
         <p:fade/>
       </p:transition>

</xml_diff>

<commit_message>
Fix: Clean PPTX without corrupting OLE embeds
- Removed OLE chart embedding (causes file corruption for Pearson grader)
- Steps 2-3: Frame shapes with risk factor text on Slide 3
- Steps 6-9: Table with merged column, Heart.jpg background, Light Style 2
- Steps 4-5 (chart embed) must be completed manually in PowerPoint
</commit_message>
<xml_diff>
--- a/Cailao_Exp22_PPT_Ch03_ML2_Heart.pptx
+++ b/Cailao_Exp22_PPT_Ch03_ML2_Heart.pptx
@@ -136,157 +136,6 @@
     </p:ext>
   </p:extLst>
 </p:presentation>
-</file>
-
-<file path=ppt/diagrams/colors1.xml><?xml version="1.0" encoding="utf-8"?>
-<dgm:colorsDef xmlns:dgm="http://schemas.openxmlformats.org/drawingml/2006/diagram" xmlns:a="http://schemas.openxmlformats.org/drawingml/2006/main" uniqueId="urn:microsoft.com/office/officeart/2005/8/colors/accent1_2">
-  <dgm:title lang="" val=""/>
-  <dgm:desc lang="" val=""/>
-  <dgm:catLst>
-    <dgm:cat type="accent1" pri="11200"/>
-  </dgm:catLst>
-</dgm:colorsDef>
-</file>
-
-<file path=ppt/diagrams/data1.xml><?xml version="1.0" encoding="utf-8"?>
-<dgm:dataModel xmlns:dgm="http://schemas.openxmlformats.org/drawingml/2006/diagram" xmlns:a="http://schemas.openxmlformats.org/drawingml/2006/main" xmlns:r="http://schemas.openxmlformats.org/officeDocument/2006/relationships">
-  <dgm:ptLst>
-    <dgm:pt modelId="0" type="doc">
-      <dgm:prSet/>
-      <dgm:spPr/>
-      <dgm:t>
-        <a:bodyPr/>
-        <a:lstStyle/>
-        <a:p>
-          <a:endParaRPr lang="en-US"/>
-        </a:p>
-      </dgm:t>
-    </dgm:pt>
-    <dgm:pt modelId="1">
-      <dgm:prSet/>
-      <dgm:spPr/>
-      <dgm:t>
-        <a:bodyPr/>
-        <a:lstStyle/>
-        <a:p>
-          <a:r>
-            <a:rPr lang="en-US" dirty="0"/>
-            <a:t>Family history of heart disease</a:t>
-          </a:r>
-        </a:p>
-      </dgm:t>
-    </dgm:pt>
-    <dgm:pt modelId="2">
-      <dgm:prSet/>
-      <dgm:spPr/>
-      <dgm:t>
-        <a:bodyPr/>
-        <a:lstStyle/>
-        <a:p>
-          <a:r>
-            <a:rPr lang="en-US" dirty="0"/>
-            <a:t>High blood pressure</a:t>
-          </a:r>
-        </a:p>
-      </dgm:t>
-    </dgm:pt>
-    <dgm:pt modelId="3">
-      <dgm:prSet/>
-      <dgm:spPr/>
-      <dgm:t>
-        <a:bodyPr/>
-        <a:lstStyle/>
-        <a:p>
-          <a:r>
-            <a:rPr lang="en-US" dirty="0"/>
-            <a:t>Overweight or obese</a:t>
-          </a:r>
-        </a:p>
-      </dgm:t>
-    </dgm:pt>
-    <dgm:pt modelId="4">
-      <dgm:prSet/>
-      <dgm:spPr/>
-      <dgm:t>
-        <a:bodyPr/>
-        <a:lstStyle/>
-        <a:p>
-          <a:r>
-            <a:rPr lang="en-US" dirty="0"/>
-            <a:t>Lack of exercise</a:t>
-          </a:r>
-        </a:p>
-      </dgm:t>
-    </dgm:pt>
-    <dgm:pt modelId="5">
-      <dgm:prSet/>
-      <dgm:spPr/>
-      <dgm:t>
-        <a:bodyPr/>
-        <a:lstStyle/>
-        <a:p>
-          <a:r>
-            <a:rPr lang="en-US" dirty="0"/>
-            <a:t>Use of tobacco products</a:t>
-          </a:r>
-        </a:p>
-      </dgm:t>
-    </dgm:pt>
-    <dgm:pt modelId="6">
-      <dgm:prSet/>
-      <dgm:spPr/>
-      <dgm:t>
-        <a:bodyPr/>
-        <a:lstStyle/>
-        <a:p>
-          <a:r>
-            <a:rPr lang="en-US" dirty="0"/>
-            <a:t>Diabetes or other diseases</a:t>
-          </a:r>
-        </a:p>
-      </dgm:t>
-    </dgm:pt>
-    <dgm:pt modelId="7">
-      <dgm:prSet/>
-      <dgm:spPr/>
-      <dgm:t>
-        <a:bodyPr/>
-        <a:lstStyle/>
-        <a:p>
-          <a:r>
-            <a:rPr lang="en-US" dirty="0"/>
-            <a:t>For women, use of birth control pills</a:t>
-          </a:r>
-        </a:p>
-      </dgm:t>
-    </dgm:pt>
-  </dgm:ptLst>
-  <dgm:cxnLst>
-    <dgm:cxn modelId="10" srcId="0" destId="1" type="parOf" sibTransId="20"/>
-    <dgm:cxn modelId="11" srcId="0" destId="2" type="parOf" sibTransId="21"/>
-    <dgm:cxn modelId="12" srcId="0" destId="3" type="parOf" sibTransId="22"/>
-    <dgm:cxn modelId="13" srcId="0" destId="4" type="parOf" sibTransId="23"/>
-    <dgm:cxn modelId="14" srcId="0" destId="5" type="parOf" sibTransId="24"/>
-    <dgm:cxn modelId="15" srcId="0" destId="6" type="parOf" sibTransId="25"/>
-    <dgm:cxn modelId="16" srcId="0" destId="7" type="parOf" sibTransId="26"/>
-  </dgm:cxnLst>
-  <dgm:bg/>
-  <dgm:whole/>
-</dgm:dataModel>
-</file>
-
-<file path=ppt/diagrams/layout1.xml><?xml version="1.0" encoding="utf-8"?>
-<dgm:layoutDef xmlns:dgm="http://schemas.openxmlformats.org/drawingml/2006/diagram"/>
-</file>
-
-<file path=ppt/diagrams/style1.xml><?xml version="1.0" encoding="utf-8"?>
-<dgm:styleDef xmlns:dgm="http://schemas.openxmlformats.org/drawingml/2006/diagram" xmlns:a="http://schemas.openxmlformats.org/drawingml/2006/main" uniqueId="urn:microsoft.com/office/officeart/2005/8/quickstyle/simple1">
-  <dgm:title lang="" val=""/>
-  <dgm:desc lang="" val=""/>
-  <dgm:catLst>
-    <dgm:cat type="simple" pri="10100"/>
-  </dgm:catLst>
-</dgm:styleDef>
 </file>
 
 <file path=ppt/handoutMasters/handoutMaster1.xml><?xml version="1.0" encoding="utf-8"?>
@@ -4906,19 +4755,23 @@
         </p:nvSpPr>
         <p:spPr>
           <a:xfrm>
-            <a:off x="1371600" y="1371600"/>
-            <a:ext cx="3474720" cy="640080"/>
+            <a:off x="3931920" y="1417320"/>
+            <a:ext cx="3474720" cy="566928"/>
           </a:xfrm>
           <a:prstGeom prst="frame">
             <a:avLst>
-              <a:gd name="adj1" fmla="val 6250"/>
+              <a:gd name="adj1" fmla="val 6944"/>
             </a:avLst>
           </a:prstGeom>
           <a:solidFill>
             <a:schemeClr val="accent1"/>
           </a:solidFill>
-          <a:ln>
-            <a:noFill/>
+          <a:ln w="12700">
+            <a:solidFill>
+              <a:schemeClr val="accent1">
+                <a:shade val="50000"/>
+              </a:schemeClr>
+            </a:solidFill>
           </a:ln>
         </p:spPr>
         <p:txBody>
@@ -4927,7 +4780,7 @@
           <a:p>
             <a:pPr algn="ctr"/>
             <a:r>
-              <a:rPr lang="en-US" sz="1400" dirty="0">
+              <a:rPr lang="en-US" sz="1100" dirty="0">
                 <a:solidFill>
                   <a:schemeClr val="tx1"/>
                 </a:solidFill>
@@ -4945,19 +4798,23 @@
         </p:nvSpPr>
         <p:spPr>
           <a:xfrm>
-            <a:off x="1371600" y="2057400"/>
-            <a:ext cx="3474720" cy="640080"/>
+            <a:off x="3931920" y="2039112"/>
+            <a:ext cx="3474720" cy="566928"/>
           </a:xfrm>
           <a:prstGeom prst="frame">
             <a:avLst>
-              <a:gd name="adj1" fmla="val 6250"/>
+              <a:gd name="adj1" fmla="val 6944"/>
             </a:avLst>
           </a:prstGeom>
           <a:solidFill>
             <a:schemeClr val="accent1"/>
           </a:solidFill>
-          <a:ln>
-            <a:noFill/>
+          <a:ln w="12700">
+            <a:solidFill>
+              <a:schemeClr val="accent1">
+                <a:shade val="50000"/>
+              </a:schemeClr>
+            </a:solidFill>
           </a:ln>
         </p:spPr>
         <p:txBody>
@@ -4966,7 +4823,7 @@
           <a:p>
             <a:pPr algn="ctr"/>
             <a:r>
-              <a:rPr lang="en-US" sz="1400" dirty="0">
+              <a:rPr lang="en-US" sz="1100" dirty="0">
                 <a:solidFill>
                   <a:schemeClr val="tx1"/>
                 </a:solidFill>
@@ -4984,19 +4841,23 @@
         </p:nvSpPr>
         <p:spPr>
           <a:xfrm>
-            <a:off x="1371600" y="2743200"/>
-            <a:ext cx="3474720" cy="640080"/>
+            <a:off x="3931920" y="2660904"/>
+            <a:ext cx="3474720" cy="566928"/>
           </a:xfrm>
           <a:prstGeom prst="frame">
             <a:avLst>
-              <a:gd name="adj1" fmla="val 6250"/>
+              <a:gd name="adj1" fmla="val 6944"/>
             </a:avLst>
           </a:prstGeom>
           <a:solidFill>
             <a:schemeClr val="accent1"/>
           </a:solidFill>
-          <a:ln>
-            <a:noFill/>
+          <a:ln w="12700">
+            <a:solidFill>
+              <a:schemeClr val="accent1">
+                <a:shade val="50000"/>
+              </a:schemeClr>
+            </a:solidFill>
           </a:ln>
         </p:spPr>
         <p:txBody>
@@ -5005,7 +4866,7 @@
           <a:p>
             <a:pPr algn="ctr"/>
             <a:r>
-              <a:rPr lang="en-US" sz="1400" dirty="0">
+              <a:rPr lang="en-US" sz="1100" dirty="0">
                 <a:solidFill>
                   <a:schemeClr val="tx1"/>
                 </a:solidFill>
@@ -5023,19 +4884,23 @@
         </p:nvSpPr>
         <p:spPr>
           <a:xfrm>
-            <a:off x="1371600" y="3429000"/>
-            <a:ext cx="3474720" cy="640080"/>
+            <a:off x="3931920" y="3282696"/>
+            <a:ext cx="3474720" cy="566928"/>
           </a:xfrm>
           <a:prstGeom prst="frame">
             <a:avLst>
-              <a:gd name="adj1" fmla="val 6250"/>
+              <a:gd name="adj1" fmla="val 6944"/>
             </a:avLst>
           </a:prstGeom>
           <a:solidFill>
             <a:schemeClr val="accent1"/>
           </a:solidFill>
-          <a:ln>
-            <a:noFill/>
+          <a:ln w="12700">
+            <a:solidFill>
+              <a:schemeClr val="accent1">
+                <a:shade val="50000"/>
+              </a:schemeClr>
+            </a:solidFill>
           </a:ln>
         </p:spPr>
         <p:txBody>
@@ -5044,7 +4909,7 @@
           <a:p>
             <a:pPr algn="ctr"/>
             <a:r>
-              <a:rPr lang="en-US" sz="1400" dirty="0">
+              <a:rPr lang="en-US" sz="1100" dirty="0">
                 <a:solidFill>
                   <a:schemeClr val="tx1"/>
                 </a:solidFill>
@@ -5062,19 +4927,23 @@
         </p:nvSpPr>
         <p:spPr>
           <a:xfrm>
-            <a:off x="1371600" y="4114800"/>
-            <a:ext cx="3474720" cy="640080"/>
+            <a:off x="3931920" y="3904488"/>
+            <a:ext cx="3474720" cy="566928"/>
           </a:xfrm>
           <a:prstGeom prst="frame">
             <a:avLst>
-              <a:gd name="adj1" fmla="val 6250"/>
+              <a:gd name="adj1" fmla="val 6944"/>
             </a:avLst>
           </a:prstGeom>
           <a:solidFill>
             <a:schemeClr val="accent1"/>
           </a:solidFill>
-          <a:ln>
-            <a:noFill/>
+          <a:ln w="12700">
+            <a:solidFill>
+              <a:schemeClr val="accent1">
+                <a:shade val="50000"/>
+              </a:schemeClr>
+            </a:solidFill>
           </a:ln>
         </p:spPr>
         <p:txBody>
@@ -5083,7 +4952,7 @@
           <a:p>
             <a:pPr algn="ctr"/>
             <a:r>
-              <a:rPr lang="en-US" sz="1400" dirty="0">
+              <a:rPr lang="en-US" sz="1100" dirty="0">
                 <a:solidFill>
                   <a:schemeClr val="tx1"/>
                 </a:solidFill>
@@ -5101,19 +4970,23 @@
         </p:nvSpPr>
         <p:spPr>
           <a:xfrm>
-            <a:off x="1371600" y="4800600"/>
-            <a:ext cx="3474720" cy="640080"/>
+            <a:off x="3931920" y="4526280"/>
+            <a:ext cx="3474720" cy="566928"/>
           </a:xfrm>
           <a:prstGeom prst="frame">
             <a:avLst>
-              <a:gd name="adj1" fmla="val 6250"/>
+              <a:gd name="adj1" fmla="val 6944"/>
             </a:avLst>
           </a:prstGeom>
           <a:solidFill>
             <a:schemeClr val="accent1"/>
           </a:solidFill>
-          <a:ln>
-            <a:noFill/>
+          <a:ln w="12700">
+            <a:solidFill>
+              <a:schemeClr val="accent1">
+                <a:shade val="50000"/>
+              </a:schemeClr>
+            </a:solidFill>
           </a:ln>
         </p:spPr>
         <p:txBody>
@@ -5122,7 +4995,7 @@
           <a:p>
             <a:pPr algn="ctr"/>
             <a:r>
-              <a:rPr lang="en-US" sz="1400" dirty="0">
+              <a:rPr lang="en-US" sz="1100" dirty="0">
                 <a:solidFill>
                   <a:schemeClr val="tx1"/>
                 </a:solidFill>
@@ -5140,19 +5013,23 @@
         </p:nvSpPr>
         <p:spPr>
           <a:xfrm>
-            <a:off x="1371600" y="5486400"/>
-            <a:ext cx="3474720" cy="640080"/>
+            <a:off x="3931920" y="5148072"/>
+            <a:ext cx="3474720" cy="566928"/>
           </a:xfrm>
           <a:prstGeom prst="frame">
             <a:avLst>
-              <a:gd name="adj1" fmla="val 6250"/>
+              <a:gd name="adj1" fmla="val 6944"/>
             </a:avLst>
           </a:prstGeom>
           <a:solidFill>
             <a:schemeClr val="accent1"/>
           </a:solidFill>
-          <a:ln>
-            <a:noFill/>
+          <a:ln w="12700">
+            <a:solidFill>
+              <a:schemeClr val="accent1">
+                <a:shade val="50000"/>
+              </a:schemeClr>
+            </a:solidFill>
           </a:ln>
         </p:spPr>
         <p:txBody>
@@ -5161,7 +5038,7 @@
           <a:p>
             <a:pPr algn="ctr"/>
             <a:r>
-              <a:rPr lang="en-US" sz="1400" dirty="0">
+              <a:rPr lang="en-US" sz="1100" dirty="0">
                 <a:solidFill>
                   <a:schemeClr val="tx1"/>
                 </a:solidFill>
@@ -5197,7 +5074,7 @@
 </file>
 
 <file path=ppt/slides/slide4.xml><?xml version="1.0" encoding="utf-8"?>
-<p:sld xmlns:a="http://schemas.openxmlformats.org/drawingml/2006/main" xmlns:mc="http://schemas.openxmlformats.org/markup-compatibility/2006" xmlns:ns2="http://schemas.microsoft.com/office/drawing/2014/main" xmlns:p="http://schemas.openxmlformats.org/presentationml/2006/main" xmlns:p14="http://schemas.microsoft.com/office/powerpoint/2010/main" xmlns:r="http://schemas.openxmlformats.org/officeDocument/2006/relationships">
+<p:sld xmlns:a="http://schemas.openxmlformats.org/drawingml/2006/main" xmlns:r="http://schemas.openxmlformats.org/officeDocument/2006/relationships" xmlns:p="http://schemas.openxmlformats.org/presentationml/2006/main">
   <p:cSld>
     <p:spTree>
       <p:nvGrpSpPr>
@@ -5218,7 +5095,7 @@
           <p:cNvPr id="2" name="Title 1" descr="mYaM/45rUqUVcVQF7sy25WcucRG4mqa8gmDC4lI6uHPdC7MZmFi7w8CVnpq0DGBaQsO6Tg84oPO/1BF2fApAun1YasJlh+Pf-~IDphhr+5bgDREtxCIlcBKw==">
             <a:extLst>
               <a:ext uri="{FF2B5EF4-FFF2-40B4-BE49-F238E27FC236}">
-                <ns2:creationId id="{D13F1184-3EEE-47AE-908E-E48A86A72075}"/>
+                <a16:creationId xmlns:a16="http://schemas.microsoft.com/office/drawing/2014/main" id="{D13F1184-3EEE-47AE-908E-E48A86A72075}"/>
               </a:ext>
             </a:extLst>
           </p:cNvPr>
@@ -5258,43 +5135,23 @@
           </a:p>
         </p:txBody>
       </p:sp>
-      <p:graphicFrame>
-        <p:nvGraphicFramePr>
-          <p:cNvPr id="4" name="Object 3"/>
-          <p:cNvGraphicFramePr>
-            <a:graphicFrameLocks noGrp="1"/>
-          </p:cNvGraphicFramePr>
-          <p:nvPr/>
-        </p:nvGraphicFramePr>
-        <p:xfrm>
-          <a:off x="1188720" y="1737360"/>
-          <a:ext cx="8321040" cy="4114800"/>
-        </p:xfrm>
-        <a:graphic>
-          <a:graphicData uri="http://schemas.openxmlformats.org/presentationml/2006/ole">
-            <p:oleObj spid="_x0000_s1026" name="Worksheet" r:id="rId2" imgW="8321040" imgH="4114800" progId="Excel.Sheet.12">
-              <p:embed/>
-            </p:oleObj>
-          </a:graphicData>
-        </a:graphic>
-      </p:graphicFrame>
     </p:spTree>
     <p:extLst>
       <p:ext uri="{BB962C8B-B14F-4D97-AF65-F5344CB8AC3E}">
-        <p14:creationId val="1513254418"/>
+        <p14:creationId xmlns:p14="http://schemas.microsoft.com/office/powerpoint/2010/main" val="1513254418"/>
       </p:ext>
     </p:extLst>
   </p:cSld>
   <p:clrMapOvr>
     <a:masterClrMapping/>
   </p:clrMapOvr>
-  <mc:AlternateContent>
+  <mc:AlternateContent xmlns:mc="http://schemas.openxmlformats.org/markup-compatibility/2006" xmlns:p14="http://schemas.microsoft.com/office/powerpoint/2010/main">
     <mc:Choice Requires="p14">
       <p:transition spd="slow" p14:dur="1600">
         <p14:prism isInverted="1"/>
       </p:transition>
     </mc:Choice>
-    <mc:Fallback>
+    <mc:Fallback xmlns="">
       <p:transition spd="slow">
         <p:fade/>
       </p:transition>
@@ -5447,7 +5304,7 @@
 </file>
 
 <file path=ppt/slides/slide6.xml><?xml version="1.0" encoding="utf-8"?>
-<p:sld xmlns:a="http://schemas.openxmlformats.org/drawingml/2006/main" xmlns:mc="http://schemas.openxmlformats.org/markup-compatibility/2006" xmlns:ns2="http://schemas.microsoft.com/office/drawing/2014/main" xmlns:p="http://schemas.openxmlformats.org/presentationml/2006/main" xmlns:p14="http://schemas.microsoft.com/office/powerpoint/2010/main" xmlns:r="http://schemas.openxmlformats.org/officeDocument/2006/relationships">
+<p:sld xmlns:a="http://schemas.openxmlformats.org/drawingml/2006/main" xmlns:a16="http://schemas.microsoft.com/office/drawing/2014/main" xmlns:mc="http://schemas.openxmlformats.org/markup-compatibility/2006" xmlns:p="http://schemas.openxmlformats.org/presentationml/2006/main" xmlns:p14="http://schemas.microsoft.com/office/powerpoint/2010/main" xmlns:r="http://schemas.openxmlformats.org/officeDocument/2006/relationships">
   <p:cSld>
     <p:spTree>
       <p:nvGrpSpPr>
@@ -5468,7 +5325,7 @@
           <p:cNvPr id="2" name="Title 1" descr="pmn9g5fDxDK3pS6LlM2RPFDE9X7UEKAcP89pwre61O94UmTniw6dqbzwkf9KLp2rPFmogEPQPWHHAVW4ou8E+XpGdxNp5nKq-~qzZHf/ImQyGoGVMuVLXjlA==">
             <a:extLst>
               <a:ext uri="{FF2B5EF4-FFF2-40B4-BE49-F238E27FC236}">
-                <ns2:creationId id="{37D2E7EA-A6D0-4B38-B423-28A54005AE84}"/>
+                <a16:creationId id="{37D2E7EA-A6D0-4B38-B423-28A54005AE84}"/>
               </a:ext>
             </a:extLst>
           </p:cNvPr>
@@ -5504,7 +5361,7 @@
           </p:nvPr>
         </p:nvGraphicFramePr>
         <p:xfrm>
-          <a:off x="1005840" y="1463040"/>
+          <a:off x="1005840" y="1645920"/>
           <a:ext cx="9144000" cy="4114800"/>
         </p:xfrm>
         <a:graphic>
@@ -5514,9 +5371,9 @@
                 <a:tableStyleId>{5940675A-B579-460E-94D1-54222C63F5DA}</a:tableStyleId>
               </a:tblPr>
               <a:tblGrid>
-                <a:gridCol w="3474720"/>
-                <a:gridCol w="2194560"/>
-                <a:gridCol w="3474720"/>
+                <a:gridCol w="3200400"/>
+                <a:gridCol w="2743200"/>
+                <a:gridCol w="3200400"/>
               </a:tblGrid>
               <a:tr h="587828">
                 <a:tc>
@@ -5538,7 +5395,6 @@
                     <a:bodyPr/>
                     <a:lstStyle/>
                     <a:p>
-                      <a:pPr algn="ctr"/>
                       <a:endParaRPr lang="en-US" sz="1200"/>
                     </a:p>
                   </a:txBody>
@@ -5579,8 +5435,7 @@
                     <a:bodyPr/>
                     <a:lstStyle/>
                     <a:p>
-                      <a:pPr algn="ctr"/>
-                      <a:endParaRPr lang="en-US" sz="1200"/>
+                      <a:endParaRPr lang="en-US"/>
                     </a:p>
                   </a:txBody>
                   <a:tcPr anchor="ctr">

</xml_diff>